<commit_message>
Slide 3: end-to-end flowchart built in draw.io
Replaces the architecture strip and the two small screenshots with a
full flowchart: role-based sign-in, upload, the five engines and what
each consults, the database, the officer's queue and three decisions,
the ledger, and the clarification loop. The editable source is
deck/img-src/architecture.drawio; render_drawio.py renders it with
draw.io's viewer engine.

Co-Authored-By: Claude Opus 5.5 <noreply@anthropic.com>
</commit_message>
<xml_diff>
--- a/deck/SatyaPatra_SIH26261_Idea.pptx
+++ b/deck/SatyaPatra_SIH26261_Idea.pptx
@@ -758,7 +758,7 @@
           <a:lstStyle/>
           <a:p>
             <a:r>
-              <a:t>Left: every choice has a reason and a rejected alternative; ask us about any of them. Right: the portal sends documents to our API, a queue feeds five engines, results land in Postgres and the ledger. The two screenshots are the running prototype.</a:t>
+              <a:t>Left: every choice has a reason and a rejected alternative; ask us about any of them. Right, follow the arrows: the institution and the officer sign in with their own roles. Every upload goes through the API queue into five engines: Read, Check against the APH rulebook, Confirm with the issuing authority, Detect tampering using cross-college memory, See the campus on satellite data, then Decide one of the six PS statuses. Results land in the database. The officer's queue reads them riskiest first; the officer decides; every decision is written to the hash-chained ledger; a clarification goes back to the institution, which re-submits. The diagram is an editable draw.io file in our repo.</a:t>
             </a:r>
           </a:p>
         </p:txBody>
@@ -7924,7 +7924,7 @@
       </p:sp>
       <p:pic>
         <p:nvPicPr>
-          <p:cNvPr id="17415" name="Picture 17414" descr="architecture2.png"/>
+          <p:cNvPr id="17415" name="Picture 17414" descr="architecture.png"/>
           <p:cNvPicPr>
             <a:picLocks noChangeAspect="1"/>
           </p:cNvPicPr>
@@ -7939,109 +7939,23 @@
         <p:spPr>
           <a:xfrm>
             <a:off x="4892040" y="1417320"/>
-            <a:ext cx="6931152" cy="2132662"/>
+            <a:ext cx="6931152" cy="4223052"/>
           </a:xfrm>
           <a:prstGeom prst="rect">
             <a:avLst/>
           </a:prstGeom>
         </p:spPr>
       </p:pic>
-      <p:pic>
-        <p:nvPicPr>
-          <p:cNvPr id="17416" name="Picture 17415" descr="shot_verify.png"/>
-          <p:cNvPicPr>
-            <a:picLocks noChangeAspect="1"/>
-          </p:cNvPicPr>
-          <p:nvPr/>
-        </p:nvPicPr>
-        <p:blipFill>
-          <a:blip r:embed="rId5"/>
-          <a:stretch>
-            <a:fillRect/>
-          </a:stretch>
-        </p:blipFill>
-        <p:spPr>
-          <a:xfrm>
-            <a:off x="4892040" y="3639312"/>
-            <a:ext cx="3690638" cy="1307101"/>
-          </a:xfrm>
-          <a:prstGeom prst="rect">
-            <a:avLst/>
-          </a:prstGeom>
-        </p:spPr>
-      </p:pic>
-      <p:pic>
-        <p:nvPicPr>
-          <p:cNvPr id="17417" name="Picture 17416" descr="shot_geo.png"/>
-          <p:cNvPicPr>
-            <a:picLocks noChangeAspect="1"/>
-          </p:cNvPicPr>
-          <p:nvPr/>
-        </p:nvPicPr>
-        <p:blipFill>
-          <a:blip r:embed="rId6"/>
-          <a:stretch>
-            <a:fillRect/>
-          </a:stretch>
-        </p:blipFill>
-        <p:spPr>
-          <a:xfrm>
-            <a:off x="8692408" y="3639312"/>
-            <a:ext cx="3130781" cy="1307101"/>
-          </a:xfrm>
-          <a:prstGeom prst="rect">
-            <a:avLst/>
-          </a:prstGeom>
-        </p:spPr>
-      </p:pic>
-      <p:sp>
-        <p:nvSpPr>
-          <p:cNvPr id="17418" name="TextBox 17417"/>
-          <p:cNvSpPr txBox="1"/>
-          <p:nvPr/>
-        </p:nvSpPr>
-        <p:spPr>
-          <a:xfrm>
-            <a:off x="4892040" y="5056632"/>
-            <a:ext cx="6931152" cy="237744"/>
-          </a:xfrm>
-          <a:prstGeom prst="rect">
-            <a:avLst/>
-          </a:prstGeom>
-          <a:noFill/>
-        </p:spPr>
-        <p:txBody>
-          <a:bodyPr wrap="square" lIns="36576" rIns="36576" tIns="18288" bIns="18288" anchor="t"/>
-          <a:lstStyle/>
-          <a:p>
-            <a:pPr algn="l">
-              <a:spcAft>
-                <a:spcPts val="300"/>
-              </a:spcAft>
-              <a:buNone/>
-            </a:pPr>
-            <a:r>
-              <a:rPr sz="850" b="0" i="1" u="none">
-                <a:solidFill>
-                  <a:srgbClr val="5B6476"/>
-                </a:solidFill>
-                <a:latin typeface="Arial"/>
-              </a:rPr>
-              <a:t>Working prototype: a forged NOC checked in 0.26 s, issuer lookup included (left); claimed built-up area vs building footprints (right)</a:t>
-            </a:r>
-          </a:p>
-        </p:txBody>
-      </p:sp>
-      <p:sp>
-        <p:nvSpPr>
-          <p:cNvPr id="17419" name="Rounded Rectangle 17418"/>
+      <p:sp>
+        <p:nvSpPr>
+          <p:cNvPr id="17416" name="Rounded Rectangle 17415"/>
           <p:cNvSpPr/>
           <p:nvPr/>
         </p:nvSpPr>
         <p:spPr>
           <a:xfrm>
-            <a:off x="4892040" y="5376672"/>
-            <a:ext cx="2249424" cy="795528"/>
+            <a:off x="4892040" y="5715000"/>
+            <a:ext cx="2249424" cy="457200"/>
           </a:xfrm>
           <a:prstGeom prst="roundRect">
             <a:avLst>
@@ -8080,14 +7994,14 @@
       </p:sp>
       <p:sp>
         <p:nvSpPr>
-          <p:cNvPr id="17420" name="TextBox 17419"/>
+          <p:cNvPr id="17417" name="TextBox 17416"/>
           <p:cNvSpPr txBox="1"/>
           <p:nvPr/>
         </p:nvSpPr>
         <p:spPr>
           <a:xfrm>
-            <a:off x="4965192" y="5413248"/>
-            <a:ext cx="2103120" cy="731520"/>
+            <a:off x="4965192" y="5733288"/>
+            <a:ext cx="2103120" cy="420624"/>
           </a:xfrm>
           <a:prstGeom prst="rect">
             <a:avLst/>
@@ -8095,7 +8009,7 @@
           <a:noFill/>
         </p:spPr>
         <p:txBody>
-          <a:bodyPr wrap="square" lIns="36576" rIns="36576" tIns="18288" bIns="18288" anchor="t"/>
+          <a:bodyPr wrap="square" lIns="36576" rIns="36576" tIns="18288" bIns="18288" anchor="ctr"/>
           <a:lstStyle/>
           <a:p>
             <a:pPr algn="l">
@@ -8105,24 +8019,16 @@
               <a:buNone/>
             </a:pPr>
             <a:r>
-              <a:rPr sz="1100" b="1" i="0" u="none">
+              <a:rPr sz="950" b="1" i="0" u="none">
                 <a:solidFill>
                   <a:srgbClr val="1F3864"/>
                 </a:solidFill>
                 <a:latin typeface="Arial"/>
               </a:rPr>
-              <a:t>1  Built</a:t>
-            </a:r>
-          </a:p>
-          <a:p>
-            <a:pPr algn="l">
-              <a:spcAft>
-                <a:spcPts val="300"/>
-              </a:spcAft>
-              <a:buNone/>
-            </a:pPr>
-            <a:r>
-              <a:rPr sz="950" b="0" i="0" u="none">
+              <a:t>1  Built  </a:t>
+            </a:r>
+            <a:r>
+              <a:rPr sz="850" b="0" i="0" u="none">
                 <a:solidFill>
                   <a:srgbClr val="1B2333"/>
                 </a:solidFill>
@@ -8135,14 +8041,14 @@
       </p:sp>
       <p:sp>
         <p:nvSpPr>
-          <p:cNvPr id="17421" name="Rounded Rectangle 17420"/>
+          <p:cNvPr id="17418" name="Rounded Rectangle 17417"/>
           <p:cNvSpPr/>
           <p:nvPr/>
         </p:nvSpPr>
         <p:spPr>
           <a:xfrm>
-            <a:off x="7232904" y="5376672"/>
-            <a:ext cx="2249424" cy="795528"/>
+            <a:off x="7232904" y="5715000"/>
+            <a:ext cx="2249424" cy="457200"/>
           </a:xfrm>
           <a:prstGeom prst="roundRect">
             <a:avLst>
@@ -8181,14 +8087,14 @@
       </p:sp>
       <p:sp>
         <p:nvSpPr>
-          <p:cNvPr id="17422" name="TextBox 17421"/>
+          <p:cNvPr id="17419" name="TextBox 17418"/>
           <p:cNvSpPr txBox="1"/>
           <p:nvPr/>
         </p:nvSpPr>
         <p:spPr>
           <a:xfrm>
-            <a:off x="7306056" y="5413248"/>
-            <a:ext cx="2103120" cy="731520"/>
+            <a:off x="7306056" y="5733288"/>
+            <a:ext cx="2103120" cy="420624"/>
           </a:xfrm>
           <a:prstGeom prst="rect">
             <a:avLst/>
@@ -8196,7 +8102,7 @@
           <a:noFill/>
         </p:spPr>
         <p:txBody>
-          <a:bodyPr wrap="square" lIns="36576" rIns="36576" tIns="18288" bIns="18288" anchor="t"/>
+          <a:bodyPr wrap="square" lIns="36576" rIns="36576" tIns="18288" bIns="18288" anchor="ctr"/>
           <a:lstStyle/>
           <a:p>
             <a:pPr algn="l">
@@ -8206,24 +8112,16 @@
               <a:buNone/>
             </a:pPr>
             <a:r>
-              <a:rPr sz="1100" b="1" i="0" u="none">
+              <a:rPr sz="950" b="1" i="0" u="none">
                 <a:solidFill>
                   <a:srgbClr val="1F3864"/>
                 </a:solidFill>
                 <a:latin typeface="Arial"/>
               </a:rPr>
-              <a:t>2  Measured</a:t>
-            </a:r>
-          </a:p>
-          <a:p>
-            <a:pPr algn="l">
-              <a:spcAft>
-                <a:spcPts val="300"/>
-              </a:spcAft>
-              <a:buNone/>
-            </a:pPr>
-            <a:r>
-              <a:rPr sz="950" b="0" i="0" u="none">
+              <a:t>2  Measured  </a:t>
+            </a:r>
+            <a:r>
+              <a:rPr sz="850" b="0" i="0" u="none">
                 <a:solidFill>
                   <a:srgbClr val="1B2333"/>
                 </a:solidFill>
@@ -8236,14 +8134,14 @@
       </p:sp>
       <p:sp>
         <p:nvSpPr>
-          <p:cNvPr id="17423" name="Rounded Rectangle 17422"/>
+          <p:cNvPr id="17420" name="Rounded Rectangle 17419"/>
           <p:cNvSpPr/>
           <p:nvPr/>
         </p:nvSpPr>
         <p:spPr>
           <a:xfrm>
-            <a:off x="9573767" y="5376672"/>
-            <a:ext cx="2249424" cy="795528"/>
+            <a:off x="9573767" y="5715000"/>
+            <a:ext cx="2249424" cy="457200"/>
           </a:xfrm>
           <a:prstGeom prst="roundRect">
             <a:avLst>
@@ -8282,14 +8180,14 @@
       </p:sp>
       <p:sp>
         <p:nvSpPr>
-          <p:cNvPr id="17424" name="TextBox 17423"/>
+          <p:cNvPr id="17421" name="TextBox 17420"/>
           <p:cNvSpPr txBox="1"/>
           <p:nvPr/>
         </p:nvSpPr>
         <p:spPr>
           <a:xfrm>
-            <a:off x="9646919" y="5413248"/>
-            <a:ext cx="2103120" cy="731520"/>
+            <a:off x="9646919" y="5733288"/>
+            <a:ext cx="2103120" cy="420624"/>
           </a:xfrm>
           <a:prstGeom prst="rect">
             <a:avLst/>
@@ -8297,7 +8195,7 @@
           <a:noFill/>
         </p:spPr>
         <p:txBody>
-          <a:bodyPr wrap="square" lIns="36576" rIns="36576" tIns="18288" bIns="18288" anchor="t"/>
+          <a:bodyPr wrap="square" lIns="36576" rIns="36576" tIns="18288" bIns="18288" anchor="ctr"/>
           <a:lstStyle/>
           <a:p>
             <a:pPr algn="l">
@@ -8307,24 +8205,16 @@
               <a:buNone/>
             </a:pPr>
             <a:r>
-              <a:rPr sz="1100" b="1" i="0" u="none">
+              <a:rPr sz="950" b="1" i="0" u="none">
                 <a:solidFill>
                   <a:srgbClr val="1F3864"/>
                 </a:solidFill>
                 <a:latin typeface="Arial"/>
               </a:rPr>
-              <a:t>3  Pilot</a:t>
-            </a:r>
-          </a:p>
-          <a:p>
-            <a:pPr algn="l">
-              <a:spcAft>
-                <a:spcPts val="300"/>
-              </a:spcAft>
-              <a:buNone/>
-            </a:pPr>
-            <a:r>
-              <a:rPr sz="950" b="0" i="0" u="none">
+              <a:t>3  Pilot  </a:t>
+            </a:r>
+            <a:r>
+              <a:rPr sz="850" b="0" i="0" u="none">
                 <a:solidFill>
                   <a:srgbClr val="1B2333"/>
                 </a:solidFill>

</xml_diff>